<commit_message>
Deck and report: Phase 4 results (64-node weak scaling, strong scaling, long-run conservation; backup slides; report chapter 10)
</commit_message>
<xml_diff>
--- a/presentation/CCS2026_Sharma_StructurePreservingPlasma.pptx
+++ b/presentation/CCS2026_Sharma_StructurePreservingPlasma.pptx
@@ -20,6 +20,8 @@
     <p:sldId id="264" r:id="rId10"/>
     <p:sldId id="272" r:id="rId23"/>
     <p:sldId id="270" r:id="rId16"/>
+    <p:sldId id="273" r:id="rId24"/>
+    <p:sldId id="274" r:id="rId25"/>
   </p:sldIdLst>
   <p:sldSz cx="12192000" cy="6858000"/>
   <p:notesSz cx="6858000" cy="12192000"/>
@@ -877,13 +879,25 @@
           <a:p>
             <a:r>
               <a:rPr lang="en-US" dirty="0"/>
-              <a:t>Let me start with the simplest test: one charged particle in an analytic Solov'ev tokamak equilibrium, pushed for a million steps, with the gyro-frequency times the time step around 0.2. The left panel is the energy error on a log scale. RK4, in red, is very accurate per step, but its error grows secularly. By the end the energy is off by about 19 percent, and in a uniform field it reaches 52 percent. Boris, in blue, stays at round-off, about 1e-13, because with no electric field it keeps the speed exactly. TSDISCGRAD, in orange, sits near 5e-10, which is set by its nonlinear solver tolerance. The right panel, canonical toroidal momentum, tells the same story, and the inset shows the orbits overlap. The green curve is a surprise, and it is the next slide. Caveat: one particle, one passing orbit.</a:t>
+              <a:t>Let me start with the simplest test: one charged particle in an analytic Solov'ev tokamak equilibrium, pushed for a million steps, with the gyro-frequency times the time step around 0.2. The left panel is the energy error on a log scale. RK4, in red, is very accurate per step, but its error grows secularly. By the end the energy is off by about 19 percent, and in a uniform field it reaches 52 percent. Boris, in blue, stays at round-off, about 1e-13, because with no electric field it keeps the speed exactly. TSDISCGRAD, in orange, sits near 5e-10, which is set by its nonlinear solver tolerance. The right panel, canonical toroidal momentum, tells the same story, and the inset shows the orbits overlap.</a:t>
             </a:r>
           </a:p>
           <a:p>
             <a:r>
               <a:rPr lang="en-US" dirty="0"/>
-              <a:t>Source: RESULTS.md section 1 (Solov'ev table); figs/pusher_solovev.png, figs/pusher_solovev_orbit.png.</a:t>
+              <a:t>I then ran 100 times longer, 10^8 steps. Boris is still bounded, with an energy error of 1.2e-12 in the Solov'ev field, while RK4 drifts 28 percent there and 67 percent in the uniform field. The 10^8 TSDISCGRAD run did not finish: nonlinear-solver failures kept shrinking its time step, so I make no 10^8 claim for it. Details are on backup slide 14.</a:t>
+            </a:r>
+          </a:p>
+          <a:p>
+            <a:r>
+              <a:rPr lang="en-US" dirty="0"/>
+              <a:t>The green curve is a surprise, and it is the next slide. Caveat: one particle, one passing orbit.</a:t>
+            </a:r>
+          </a:p>
+          <a:p>
+            <a:r>
+              <a:rPr lang="en-US" dirty="0"/>
+              <a:t>Source: RESULTS.md section 1 (Solov'ev table) and Phase 4 'Pusher long runs'; figs/pusher_solovev.png, figs/pusher_solovev_orbit.png, figs/pusher_longrun.png.</a:t>
             </a:r>
           </a:p>
         </p:txBody>
@@ -970,19 +984,25 @@
           <a:p>
             <a:r>
               <a:rPr lang="en-US" dirty="0"/>
-              <a:t>To wrap up, three takeaways. First, structure-preserving methods keep the invariants of the physics, where a standard method like RK4 slowly drifts. Second, those same conservation checks are what make AI-generated simulation code verifiable: a generated solver either keeps its invariants, or it is rejected. Third, on leadership-class hardware, I measured a real scaling bottleneck, found its cause, and fixed it.</a:t>
+              <a:t>To wrap up, three takeaways. First, structure-preserving methods keep the invariants of the physics, where a standard method like RK4 slowly drifts, and Boris stays bounded even over 10^8 steps. Second, those same conservation checks are what make AI-generated simulation code verifiable: a generated solver either keeps its invariants, or it is rejected. Third, on leadership-class hardware, I measured a real scaling bottleneck, found its cause and fixed it, and the code now runs on 64 Aurora nodes with 315 million particles.</a:t>
             </a:r>
           </a:p>
           <a:p>
             <a:r>
               <a:rPr lang="en-US" dirty="0"/>
-              <a:t>Next, I want energy-conserving PIC; particles that live on the GPU instead of the CPU; a full end-to-end loop where the LLM agents generate, run and verify the code; larger runs on Aurora; and a move to 3D with finite-element exterior calculus.</a:t>
+              <a:t>Next, and now backed by my own data, energy-conserving PIC: the long Landau runs show the slow numerical heating that momentum-conserving PIC is known for, so I want particles and field coupled so total energy is conserved. Then particles that live on the GPU instead of the CPU; a full end-to-end loop where the LLM agents generate, run and verify the code; Aurora runs beyond 64 nodes; and a move to 3D with finite-element exterior calculus.</a:t>
             </a:r>
           </a:p>
           <a:p>
             <a:r>
               <a:rPr lang="en-US" dirty="0"/>
               <a:t>I would be glad to hear from you at ss694@buffalo.edu. This work used an ALCF Director's Discretionary allocation, DD_plasma_physics, on Aurora and Polaris at Argonne National Laboratory. Thank you.</a:t>
+            </a:r>
+          </a:p>
+          <a:p>
+            <a:r>
+              <a:rPr lang="en-US" dirty="0"/>
+              <a:t>Source: RESULTS.md Phase 4 (weak scaling to 64 nodes; long-run Landau; pusher long runs).</a:t>
             </a:r>
           </a:p>
         </p:txBody>
@@ -1069,31 +1089,235 @@
           <a:p>
             <a:r>
               <a:rPr lang="en-US" dirty="0"/>
-              <a:t>Then I asked whether it scales. In this weak-scaling test every MPI rank keeps 51,200 particles while the domain grows with the rank count.</a:t>
+              <a:t>Then I asked whether it scales. In this weak-scaling test every MPI rank keeps the same work, 256 cells and 51,200 particles, while the domain grows with the rank count. Perfect weak scaling would keep the time per step flat.</a:t>
             </a:r>
           </a:p>
           <a:p>
             <a:r>
               <a:rPr lang="en-US" dirty="0"/>
-              <a:t>At first, efficiency collapsed to about three percent. Profiling showed why: the rank that owns the periodic wrap-around cell sizes its point-location hash box over the whole domain, so it did up to 41 times the work of any other rank, and everyone waited for it. A small local patch to ex2 gives only that rank finer bins.</a:t>
+              <a:t>At first, efficiency collapsed to about three percent. Profiling showed why: the rank that owns the periodic wrap-around cell sizes its point-location hash box over the whole domain, so it did up to 41 times the work of any other rank, and everyone waited for it. A small local patch to ex2 gives only that rank finer bins. That made a step 12 times faster at 16 Aurora nodes.</a:t>
             </a:r>
           </a:p>
           <a:p>
             <a:r>
               <a:rPr lang="en-US" dirty="0"/>
-              <a:t>After the fix, Aurora holds 75 percent efficiency from 1 to 16 nodes, 1,536 ranks, and is 12 times faster per step. Polaris holds 80 percent from 1 to 8 nodes, 256 ranks, and is 14.7 times faster. Particle count and charge are exactly conserved in every run.</a:t>
+              <a:t>After the fix, measured against one full node, Aurora holds 75 percent at 16 nodes, 63 percent at 32 and 58 percent at 64 nodes: 6,144 ranks and 315 million particles. The decline is gradual; going from 32 to 64 nodes costs only 7 percent. Polaris holds 80 percent at 8 nodes. No particle was lost in any run.</a:t>
             </a:r>
           </a:p>
           <a:p>
             <a:r>
               <a:rPr lang="en-US" dirty="0"/>
-              <a:t>Caveats: this is 1D-1V, only 100 steps, and the GPU path is slower here, because only the field solve runs on the GPU.</a:t>
+              <a:t>Caveats: 1D-1V, 100 steps, CPU only, one run per point, so a few percent of noise is plausible.</a:t>
             </a:r>
           </a:p>
           <a:p>
             <a:r>
               <a:rPr lang="en-US" dirty="0"/>
-              <a:t>Source: research/results/RESULTS.md, Phase 3 Steps A and B, and Caveats.</a:t>
+              <a:t>Source: research/results/RESULTS.md, Phase 3 Steps A and B, and Phase 4 'Weak scaling extended to 64 Aurora nodes'; phase4/data/phase4_analysis.json.</a:t>
+            </a:r>
+          </a:p>
+        </p:txBody>
+      </p:sp>
+      <p:sp>
+        <p:nvSpPr>
+          <p:cNvPr id="4" name="Slide Number Placeholder 3"/>
+          <p:cNvSpPr>
+            <a:spLocks noGrp="1"/>
+          </p:cNvSpPr>
+          <p:nvPr>
+            <p:ph type="sldNum" sz="quarter" idx="10"/>
+          </p:nvPr>
+        </p:nvSpPr>
+        <p:spPr/>
+        <p:txBody>
+          <a:bodyPr/>
+          <a:lstStyle/>
+          <a:p>
+            <a:fld id="{F7021451-1387-4CA6-816F-3879F97B5CBC}" type="slidenum">
+              <a:rPr lang="en-US"/>
+              <a:t>14</a:t>
+            </a:fld>
+            <a:endParaRPr lang="en-US"/>
+          </a:p>
+        </p:txBody>
+      </p:sp>
+    </p:spTree>
+    <p:extLst>
+      <p:ext uri="{BB962C8B-B14F-4D97-AF65-F5344CB8AC3E}">
+        <p14:creationId xmlns:p14="http://schemas.microsoft.com/office/powerpoint/2010/main" val="1024086991"/>
+      </p:ext>
+    </p:extLst>
+  </p:cSld>
+  <p:clrMapOvr>
+    <a:masterClrMapping/>
+  </p:clrMapOvr>
+</p:notes>
+</file>
+
+<file path=ppt/notesSlides/notesSlide18.xml><?xml version="1.0" encoding="utf-8"?>
+<p:notes xmlns:a="http://schemas.openxmlformats.org/drawingml/2006/main" xmlns:r="http://schemas.openxmlformats.org/officeDocument/2006/relationships" xmlns:p="http://schemas.openxmlformats.org/presentationml/2006/main">
+  <p:cSld>
+    <p:spTree>
+      <p:nvGrpSpPr>
+        <p:cNvPr id="1" name=""/>
+        <p:cNvGrpSpPr/>
+        <p:nvPr/>
+      </p:nvGrpSpPr>
+      <p:grpSpPr>
+        <a:xfrm>
+          <a:off x="0" y="0"/>
+          <a:ext cx="0" cy="0"/>
+          <a:chOff x="0" y="0"/>
+          <a:chExt cx="0" cy="0"/>
+        </a:xfrm>
+      </p:grpSpPr>
+      <p:sp>
+        <p:nvSpPr>
+          <p:cNvPr id="2" name="Slide Image Placeholder 1"/>
+          <p:cNvSpPr>
+            <a:spLocks noGrp="1" noRot="1" noChangeAspect="1"/>
+          </p:cNvSpPr>
+          <p:nvPr>
+            <p:ph type="sldImg"/>
+          </p:nvPr>
+        </p:nvSpPr>
+        <p:spPr/>
+      </p:sp>
+      <p:sp>
+        <p:nvSpPr>
+          <p:cNvPr id="3" name="Notes Placeholder 2"/>
+          <p:cNvSpPr>
+            <a:spLocks noGrp="1"/>
+          </p:cNvSpPr>
+          <p:nvPr>
+            <p:ph type="body" idx="1"/>
+          </p:nvPr>
+        </p:nvSpPr>
+        <p:spPr/>
+        <p:txBody>
+          <a:bodyPr/>
+          <a:lstStyle/>
+          <a:p>
+            <a:r>
+              <a:rPr lang="en-US" dirty="0"/>
+              <a:t>Backup, if someone asks about strong scaling. Weak scaling, on slide 11, grows the problem with the machine. Strong scaling keeps one fixed problem, here 9.83 million particles on 49,152 cells for 100 steps, and asks how much faster it gets on more nodes.</a:t>
+            </a:r>
+          </a:p>
+          <a:p>
+            <a:r>
+              <a:rPr lang="en-US" dirty="0"/>
+              <a:t>On Aurora it speeds up 4.63 times at 16 nodes, an efficiency of 0.29 against one node. The reason is simple: at 1,536 ranks each rank has only 32 cells and 6,400 particles left, so communication and fixed costs dominate; going from 8 to 16 nodes gains only 10 percent. Polaris has 32 ranks per node instead of 96, keeps about six times more work per rank, and reaches 5.38 times at 8 nodes, efficiency 0.67. Per node, Aurora is 2.65 times faster than Polaris on this problem. Counting only the time-stepping, Aurora reaches 0.33 and Polaris 0.72.</a:t>
+            </a:r>
+          </a:p>
+          <a:p>
+            <a:r>
+              <a:rPr lang="en-US" dirty="0"/>
+              <a:t>Source: RESULTS.md Phase 4 'Strong scaling'; phase4/data/strong_scaling.csv; figs/strong_scaling.png.</a:t>
+            </a:r>
+          </a:p>
+        </p:txBody>
+      </p:sp>
+      <p:sp>
+        <p:nvSpPr>
+          <p:cNvPr id="4" name="Slide Number Placeholder 3"/>
+          <p:cNvSpPr>
+            <a:spLocks noGrp="1"/>
+          </p:cNvSpPr>
+          <p:nvPr>
+            <p:ph type="sldNum" sz="quarter" idx="10"/>
+          </p:nvPr>
+        </p:nvSpPr>
+        <p:spPr/>
+        <p:txBody>
+          <a:bodyPr/>
+          <a:lstStyle/>
+          <a:p>
+            <a:fld id="{F7021451-1387-4CA6-816F-3879F97B5CBC}" type="slidenum">
+              <a:rPr lang="en-US"/>
+              <a:t>14</a:t>
+            </a:fld>
+            <a:endParaRPr lang="en-US"/>
+          </a:p>
+        </p:txBody>
+      </p:sp>
+    </p:spTree>
+    <p:extLst>
+      <p:ext uri="{BB962C8B-B14F-4D97-AF65-F5344CB8AC3E}">
+        <p14:creationId xmlns:p14="http://schemas.microsoft.com/office/powerpoint/2010/main" val="1024086991"/>
+      </p:ext>
+    </p:extLst>
+  </p:cSld>
+  <p:clrMapOvr>
+    <a:masterClrMapping/>
+  </p:clrMapOvr>
+</p:notes>
+</file>
+
+<file path=ppt/notesSlides/notesSlide19.xml><?xml version="1.0" encoding="utf-8"?>
+<p:notes xmlns:a="http://schemas.openxmlformats.org/drawingml/2006/main" xmlns:r="http://schemas.openxmlformats.org/officeDocument/2006/relationships" xmlns:p="http://schemas.openxmlformats.org/presentationml/2006/main">
+  <p:cSld>
+    <p:spTree>
+      <p:nvGrpSpPr>
+        <p:cNvPr id="1" name=""/>
+        <p:cNvGrpSpPr/>
+        <p:nvPr/>
+      </p:nvGrpSpPr>
+      <p:grpSpPr>
+        <a:xfrm>
+          <a:off x="0" y="0"/>
+          <a:ext cx="0" cy="0"/>
+          <a:chOff x="0" y="0"/>
+          <a:chExt cx="0" cy="0"/>
+        </a:xfrm>
+      </p:grpSpPr>
+      <p:sp>
+        <p:nvSpPr>
+          <p:cNvPr id="2" name="Slide Image Placeholder 1"/>
+          <p:cNvSpPr>
+            <a:spLocks noGrp="1" noRot="1" noChangeAspect="1"/>
+          </p:cNvSpPr>
+          <p:nvPr>
+            <p:ph type="sldImg"/>
+          </p:nvPr>
+        </p:nvSpPr>
+        <p:spPr/>
+      </p:sp>
+      <p:sp>
+        <p:nvSpPr>
+          <p:cNvPr id="3" name="Notes Placeholder 2"/>
+          <p:cNvSpPr>
+            <a:spLocks noGrp="1"/>
+          </p:cNvSpPr>
+          <p:nvPr>
+            <p:ph type="body" idx="1"/>
+          </p:nvPr>
+        </p:nvSpPr>
+        <p:spPr/>
+        <p:txBody>
+          <a:bodyPr/>
+          <a:lstStyle/>
+          <a:p>
+            <a:r>
+              <a:rPr lang="en-US" dirty="0"/>
+              <a:t>Backup on long runs, because conservation over long times is the whole point.</a:t>
+            </a:r>
+          </a:p>
+          <a:p>
+            <a:r>
+              <a:rPr lang="en-US" dirty="0"/>
+              <a:t>Left: the particle pushers run 100 times longer than in the main talk, 10^8 steps at time step 0.2. Boris stays bounded: in the Solov'ev field the energy error is 1.2e-12 and the canonical momentum error stays near 5e-6. RK4 drifts 28 percent in Solov'ev and 67 percent in the uniform field. The 10^8 TSDISCGRAD run stalled: its nonlinear solver kept failing and the time step kept shrinking, so it reached only t of about 80 and 3 out of 2e7. Its conservation was excellent where it ran, but I do not claim a 10^8 result for it.</a:t>
+            </a:r>
+          </a:p>
+          <a:p>
+            <a:r>
+              <a:rPr lang="en-US" dirty="0"/>
+              <a:t>Right: long Landau runs of the ex2 PIC code. At time step 0.01 the energy error stays bounded near 3.8e-6 for 6,000 steps, and Aurora and Polaris agree to 1e-14. At 0.05 it is flat near 1e-4 until t of about 70, after the field has damped into the particle noise, and then grows linearly to 4.4e-3 at t = 300. With only 3,200 particles the heating reaches about 80 percent by t = 3000. That is the known numerical heating of momentum-conserving, non-energy-conserving PIC, so I do not claim bounded energy for ex2; it is the motivation for energy-conserving PIC. The damping-rate fit at 0.05 is −0.147 versus theory −0.1533.</a:t>
+            </a:r>
+          </a:p>
+          <a:p>
+            <a:r>
+              <a:rPr lang="en-US" dirty="0"/>
+              <a:t>Source: RESULTS.md Phase 4 'Long-run Landau damping' and 'Pusher long runs'; figs/landau_longrun.png, figs/pusher_longrun.png.</a:t>
             </a:r>
           </a:p>
         </p:txBody>
@@ -1557,25 +1781,25 @@
           <a:p>
             <a:r>
               <a:rPr lang="en-US" dirty="0"/>
-              <a:t>On the left, the electric field decays. My fitted damping rate is −0.161, against linear theory's −0.1533, about five percent steeper, which is reasonable for an envelope fit on a 256-cell mesh.</a:t>
+              <a:t>On the left, the electric field decays. My fitted damping rate is −0.161, against linear theory's −0.1533. A longer 6,000-step run gives −0.147, so the fit is within about five percent either way.</a:t>
             </a:r>
           </a:p>
           <a:p>
             <a:r>
               <a:rPr lang="en-US" dirty="0"/>
-              <a:t>The results are identical on both machines, to every printed digit, and they do not change with the number of MPI ranks.</a:t>
+              <a:t>The results are identical on both machines and do not change with the number of MPI ranks. In a 6,000-step run at time step 0.01, Aurora and Polaris agree to 1e-14 in total energy.</a:t>
             </a:r>
           </a:p>
           <a:p>
             <a:r>
               <a:rPr lang="en-US" dirty="0"/>
-              <a:t>On the right, total energy drifts by about one part in a hundred thousand over 600 steps. That is small, but it is not exact conservation: this scheme is symplectic only for a frozen field. That is why energy-conserving PIC is one of my next steps.</a:t>
+              <a:t>On the right, total energy changes by about one part in a hundred thousand over these 600 steps. I want to be clear that this is not bounded: in long runs at time step 0.05 the error is flat near 1e-4 until t of about 70, then grows linearly to 0.4 percent at t = 300, and a coarse 3,200-particle run heats by about 80 percent by t = 3000. That is the known numerical heating of PIC schemes that conserve momentum but not energy, and it is why energy-conserving PIC is my first next step. Backup slide 14 has the plots.</a:t>
             </a:r>
           </a:p>
           <a:p>
             <a:r>
               <a:rPr lang="en-US" dirty="0"/>
-              <a:t>Source: research/results/RESULTS.md, section 3 (physics/conservation table).</a:t>
+              <a:t>Source: research/results/RESULTS.md, section 3 and Phase 4 'Long-run Landau damping'.</a:t>
             </a:r>
           </a:p>
         </p:txBody>
@@ -4471,66 +4695,122 @@
         </p:nvSpPr>
         <p:spPr>
           <a:xfrm>
-            <a:off x="702259" y="5138928"/>
-            <a:ext cx="10789920" cy="868680"/>
-          </a:xfrm>
-          <a:prstGeom prst="rect">
-            <a:avLst/>
-          </a:prstGeom>
-          <a:noFill/>
-          <a:ln/>
-        </p:spPr>
-        <p:txBody>
-          <a:bodyPr wrap="square" rtlCol="0" anchor="t"/>
-          <a:lstStyle/>
-          <a:p>
-            <a:pPr algn="l" indent="0" marL="0">
-              <a:buNone/>
-            </a:pPr>
-            <a:r>
-              <a:rPr lang="en-US" sz="1800" dirty="0">
-                <a:solidFill>
-                  <a:srgbClr val="000000"/>
-                </a:solidFill>
-                <a:latin typeface="Lexend" pitchFamily="34" charset="0"/>
-                <a:ea typeface="Lexend" pitchFamily="34" charset="-122"/>
-                <a:cs typeface="Lexend" pitchFamily="34" charset="-120"/>
+            <a:off x="702259" y="5074920"/>
+            <a:ext cx="10789920" cy="1188720"/>
+          </a:xfrm>
+          <a:prstGeom prst="rect">
+            <a:avLst/>
+          </a:prstGeom>
+          <a:noFill/>
+          <a:ln/>
+        </p:spPr>
+        <p:txBody>
+          <a:bodyPr wrap="square" rtlCol="0" anchor="t"/>
+          <a:lstStyle/>
+          <a:p>
+            <a:pPr algn="l">
+              <a:spcAft>
+                <a:spcPts val="600"/>
+              </a:spcAft>
+              <a:buNone/>
+            </a:pPr>
+            <a:r>
+              <a:rPr lang="en-US" sz="1700" dirty="0">
+                <a:solidFill>
+                  <a:srgbClr val="000000"/>
+                </a:solidFill>
+                <a:latin typeface="Lexend"/>
+                <a:cs typeface="Lexend"/>
               </a:rPr>
               <a:t>10</a:t>
             </a:r>
             <a:r>
-              <a:rPr lang="en-US" sz="1800" dirty="0" baseline="30000">
-                <a:solidFill>
-                  <a:srgbClr val="000000"/>
-                </a:solidFill>
-                <a:latin typeface="Lexend" pitchFamily="34" charset="0"/>
-                <a:ea typeface="Lexend" pitchFamily="34" charset="-122"/>
-                <a:cs typeface="Lexend" pitchFamily="34" charset="-120"/>
+              <a:rPr lang="en-US" sz="1700" dirty="0" baseline="30000">
+                <a:solidFill>
+                  <a:srgbClr val="000000"/>
+                </a:solidFill>
+                <a:latin typeface="Lexend"/>
+                <a:cs typeface="Lexend"/>
               </a:rPr>
               <a:t>6</a:t>
             </a:r>
             <a:r>
-              <a:rPr lang="en-US" sz="1800" dirty="0">
-                <a:solidFill>
-                  <a:srgbClr val="000000"/>
-                </a:solidFill>
-                <a:latin typeface="Lexend" pitchFamily="34" charset="0"/>
-                <a:ea typeface="Lexend" pitchFamily="34" charset="-122"/>
-                <a:cs typeface="Lexend" pitchFamily="34" charset="-120"/>
+              <a:rPr lang="en-US" sz="1700" dirty="0">
+                <a:solidFill>
+                  <a:srgbClr val="000000"/>
+                </a:solidFill>
+                <a:latin typeface="Lexend"/>
+                <a:cs typeface="Lexend"/>
               </a:rPr>
               <a:t> steps in a Solov'ev tokamak field: RK4 energy drifts 19% (52% in uniform B). </a:t>
             </a:r>
             <a:r>
-              <a:rPr lang="en-US" sz="1800" dirty="0">
+              <a:rPr lang="en-US" sz="1700" dirty="0">
                 <a:solidFill>
                   <a:srgbClr val="03BA81"/>
                 </a:solidFill>
-                <a:latin typeface="Lexend" pitchFamily="34" charset="0"/>
-                <a:ea typeface="Lexend" pitchFamily="34" charset="-122"/>
-                <a:cs typeface="Lexend" pitchFamily="34" charset="-120"/>
+                <a:latin typeface="Lexend"/>
+                <a:cs typeface="Lexend"/>
               </a:rPr>
               <a:t>Boris stays at round-off; TSDISCGRAD at solver tolerance.</a:t>
             </a:r>
+            <a:endParaRPr lang="en-US" sz="1700"/>
+          </a:p>
+          <a:p>
+            <a:pPr algn="l">
+              <a:buNone/>
+            </a:pPr>
+            <a:r>
+              <a:rPr lang="en-US" sz="1500" dirty="0">
+                <a:solidFill>
+                  <a:srgbClr val="404040"/>
+                </a:solidFill>
+                <a:latin typeface="Poppins"/>
+                <a:cs typeface="Poppins"/>
+              </a:rPr>
+              <a:t>100× longer (10</a:t>
+            </a:r>
+            <a:r>
+              <a:rPr lang="en-US" sz="1500" dirty="0" baseline="30000">
+                <a:solidFill>
+                  <a:srgbClr val="404040"/>
+                </a:solidFill>
+                <a:latin typeface="Poppins"/>
+                <a:cs typeface="Poppins"/>
+              </a:rPr>
+              <a:t>8</a:t>
+            </a:r>
+            <a:r>
+              <a:rPr lang="en-US" sz="1500" dirty="0">
+                <a:solidFill>
+                  <a:srgbClr val="404040"/>
+                </a:solidFill>
+                <a:latin typeface="Poppins"/>
+                <a:cs typeface="Poppins"/>
+              </a:rPr>
+              <a:t> steps): Boris still bounded (energy error 1.2×10</a:t>
+            </a:r>
+            <a:r>
+              <a:rPr lang="en-US" sz="1500" dirty="0" baseline="30000">
+                <a:solidFill>
+                  <a:srgbClr val="404040"/>
+                </a:solidFill>
+                <a:latin typeface="Poppins"/>
+                <a:cs typeface="Poppins"/>
+              </a:rPr>
+              <a:t>−12</a:t>
+            </a:r>
+            <a:r>
+              <a:rPr lang="en-US" sz="1500" dirty="0">
+                <a:solidFill>
+                  <a:srgbClr val="404040"/>
+                </a:solidFill>
+                <a:latin typeface="Poppins"/>
+                <a:cs typeface="Poppins"/>
+              </a:rPr>
+              <a:t>); RK4 drifts 28% (67% in uniform B).</a:t>
+            </a:r>
+            <a:endParaRPr lang="en-US" sz="1500"/>
           </a:p>
         </p:txBody>
       </p:sp>
@@ -4754,7 +5034,7 @@
           <a:p>
             <a:pPr algn="l">
               <a:spcAft>
-                <a:spcPts val="1600"/>
+                <a:spcPts val="1400"/>
               </a:spcAft>
               <a:buNone/>
             </a:pPr>
@@ -4783,7 +5063,7 @@
           <a:p>
             <a:pPr algn="l">
               <a:spcAft>
-                <a:spcPts val="1600"/>
+                <a:spcPts val="1400"/>
               </a:spcAft>
               <a:buNone/>
             </a:pPr>
@@ -4812,7 +5092,7 @@
           <a:p>
             <a:pPr algn="l">
               <a:spcAft>
-                <a:spcPts val="1600"/>
+                <a:spcPts val="1400"/>
               </a:spcAft>
               <a:buNone/>
             </a:pPr>
@@ -4834,7 +5114,7 @@
                 <a:latin typeface="Poppins"/>
                 <a:cs typeface="Poppins"/>
               </a:rPr>
-              <a:t>We measured and fixed a real scaling bottleneck on Aurora.</a:t>
+              <a:t>We fixed a real scaling bottleneck; ex2 now runs on 64 Aurora nodes.</a:t>
             </a:r>
             <a:endParaRPr lang="en-US" sz="2000"/>
           </a:p>
@@ -4943,18 +5223,60 @@
         </p:nvSpPr>
         <p:spPr>
           <a:xfrm>
-            <a:off x="7528255" y="1874520"/>
-            <a:ext cx="4206240" cy="2103120"/>
-          </a:xfrm>
-          <a:prstGeom prst="rect">
-            <a:avLst/>
-          </a:prstGeom>
-          <a:noFill/>
-          <a:ln/>
-        </p:spPr>
-        <p:txBody>
-          <a:bodyPr wrap="square" rtlCol="0" anchor="t"/>
-          <a:lstStyle/>
+            <a:off x="7528255" y="1783080"/>
+            <a:ext cx="4206240" cy="2194560"/>
+          </a:xfrm>
+          <a:prstGeom prst="rect">
+            <a:avLst/>
+          </a:prstGeom>
+          <a:noFill/>
+          <a:ln/>
+        </p:spPr>
+        <p:txBody>
+          <a:bodyPr wrap="square" rtlCol="0" anchor="t"/>
+          <a:lstStyle/>
+          <a:p>
+            <a:pPr algn="l" marL="285750" indent="-285750">
+              <a:spcAft>
+                <a:spcPts val="0"/>
+              </a:spcAft>
+              <a:buClr>
+                <a:srgbClr val="03BA81"/>
+              </a:buClr>
+              <a:buFont typeface="Arial"/>
+              <a:buChar char="•"/>
+            </a:pPr>
+            <a:r>
+              <a:rPr lang="en-US" sz="1800" dirty="0" b="1">
+                <a:solidFill>
+                  <a:srgbClr val="000000"/>
+                </a:solidFill>
+                <a:latin typeface="Poppins"/>
+                <a:cs typeface="Poppins"/>
+              </a:rPr>
+              <a:t>Energy-conserving PIC</a:t>
+            </a:r>
+            <a:endParaRPr lang="en-US" sz="1800"/>
+          </a:p>
+          <a:p>
+            <a:pPr algn="l" marL="285750">
+              <a:spcAft>
+                <a:spcPts val="800"/>
+              </a:spcAft>
+              <a:buNone/>
+            </a:pPr>
+            <a:r>
+              <a:rPr lang="en-US" sz="1300" dirty="0">
+                <a:solidFill>
+                  <a:srgbClr val="404040"/>
+                </a:solidFill>
+                <a:latin typeface="Poppins"/>
+                <a:cs typeface="Poppins"/>
+              </a:rPr>
+              <a:t>long runs show numerical heating</a:t>
+            </a:r>
+            <a:endParaRPr lang="en-US" sz="1300"/>
+          </a:p>
           <a:p>
             <a:pPr algn="l" marL="285750" indent="-285750">
               <a:spcAft>
@@ -4974,7 +5296,7 @@
                 <a:latin typeface="Poppins"/>
                 <a:cs typeface="Poppins"/>
               </a:rPr>
-              <a:t>Energy-conserving PIC</a:t>
+              <a:t>GPU-resident particles</a:t>
             </a:r>
             <a:endParaRPr lang="en-US" sz="1800"/>
           </a:p>
@@ -4997,7 +5319,7 @@
                 <a:latin typeface="Poppins"/>
                 <a:cs typeface="Poppins"/>
               </a:rPr>
-              <a:t>GPU-resident particles</a:t>
+              <a:t>End-to-end LLM agent loop</a:t>
             </a:r>
             <a:endParaRPr lang="en-US" sz="1800"/>
           </a:p>
@@ -5020,37 +5342,14 @@
                 <a:latin typeface="Poppins"/>
                 <a:cs typeface="Poppins"/>
               </a:rPr>
-              <a:t>End-to-end LLM agent loop</a:t>
+              <a:t>Aurora beyond 64 nodes</a:t>
             </a:r>
             <a:endParaRPr lang="en-US" sz="1800"/>
           </a:p>
           <a:p>
             <a:pPr algn="l" marL="285750" indent="-285750">
               <a:spcAft>
-                <a:spcPts val="800"/>
-              </a:spcAft>
-              <a:buClr>
-                <a:srgbClr val="03BA81"/>
-              </a:buClr>
-              <a:buFont typeface="Arial"/>
-              <a:buChar char="•"/>
-            </a:pPr>
-            <a:r>
-              <a:rPr lang="en-US" sz="1800" dirty="0">
-                <a:solidFill>
-                  <a:srgbClr val="000000"/>
-                </a:solidFill>
-                <a:latin typeface="Poppins"/>
-                <a:cs typeface="Poppins"/>
-              </a:rPr>
-              <a:t>Larger runs on Aurora</a:t>
-            </a:r>
-            <a:endParaRPr lang="en-US" sz="1800"/>
-          </a:p>
-          <a:p>
-            <a:pPr algn="l" marL="285750" indent="-285750">
-              <a:spcAft>
-                <a:spcPts val="800"/>
+                <a:spcPts val="0"/>
               </a:spcAft>
               <a:buClr>
                 <a:srgbClr val="03BA81"/>
@@ -5330,7 +5629,7 @@
                 <a:latin typeface="Lexend"/>
                 <a:cs typeface="Lexend"/>
               </a:rPr>
-              <a:t>one fix, 12× faster</a:t>
+              <a:t>fixed, then 64 nodes</a:t>
             </a:r>
             <a:endParaRPr lang="en-US" sz="4000"/>
           </a:p>
@@ -5358,9 +5657,87 @@
           <a:ln/>
         </p:spPr>
       </p:sp>
+      <p:sp>
+        <p:nvSpPr>
+          <p:cNvPr id="75" name="TextBox 75"/>
+          <p:cNvSpPr txBox="1">
+            <a:spLocks noGrp="1"/>
+          </p:cNvSpPr>
+          <p:nvPr/>
+        </p:nvSpPr>
+        <p:spPr>
+          <a:xfrm>
+            <a:off x="612648" y="5120640"/>
+            <a:ext cx="10972800" cy="1143000"/>
+          </a:xfrm>
+          <a:prstGeom prst="rect">
+            <a:avLst/>
+          </a:prstGeom>
+          <a:noFill/>
+        </p:spPr>
+        <p:txBody>
+          <a:bodyPr lIns="0" tIns="0" rIns="0" bIns="0" wrap="square"/>
+          <a:lstStyle/>
+          <a:p>
+            <a:pPr algn="l">
+              <a:spcAft>
+                <a:spcPts val="600"/>
+              </a:spcAft>
+              <a:buNone/>
+            </a:pPr>
+            <a:r>
+              <a:rPr lang="en-US" sz="1500" dirty="0" b="1">
+                <a:solidFill>
+                  <a:srgbClr val="03BA81"/>
+                </a:solidFill>
+                <a:latin typeface="Poppins"/>
+                <a:cs typeface="Poppins"/>
+              </a:rPr>
+              <a:t>Cause: </a:t>
+            </a:r>
+            <a:r>
+              <a:rPr lang="en-US" sz="1500" dirty="0">
+                <a:solidFill>
+                  <a:srgbClr val="000000"/>
+                </a:solidFill>
+                <a:latin typeface="Poppins"/>
+                <a:cs typeface="Poppins"/>
+              </a:rPr>
+              <a:t>the periodic-wrap rank’s point-location hash spanned the whole domain, so one rank did up to 41× the work. A local ex2 patch fixed it (before: 3% efficiency).</a:t>
+            </a:r>
+            <a:endParaRPr lang="en-US" sz="1500"/>
+          </a:p>
+          <a:p>
+            <a:pPr algn="l">
+              <a:buNone/>
+            </a:pPr>
+            <a:r>
+              <a:rPr lang="en-US" sz="1500" dirty="0" b="1">
+                <a:solidFill>
+                  <a:srgbClr val="03BA81"/>
+                </a:solidFill>
+                <a:latin typeface="Poppins"/>
+                <a:cs typeface="Poppins"/>
+              </a:rPr>
+              <a:t>Efficiency vs 1 node (TSStep): </a:t>
+            </a:r>
+            <a:r>
+              <a:rPr lang="en-US" sz="1500" dirty="0">
+                <a:solidFill>
+                  <a:srgbClr val="000000"/>
+                </a:solidFill>
+                <a:latin typeface="Poppins"/>
+                <a:cs typeface="Poppins"/>
+              </a:rPr>
+              <a:t>1.00 / 0.90 / 0.87 / 0.82 / 0.75 / 0.63 / 0.58 at 1, 2, 4, 8, 16, 32, 64 nodes.</a:t>
+            </a:r>
+            <a:endParaRPr lang="en-US" sz="1500"/>
+          </a:p>
+        </p:txBody>
+      </p:sp>
       <p:pic>
         <p:nvPicPr>
-          <p:cNvPr id="70" name="Picture 70" descr="Weak scaling efficiency on Aurora and Polaris, and Aurora time breakdown before and after the fix"/>
+          <p:cNvPr id="70" name="Picture 70" descr="Weak-scaling efficiency vs 1 node on Aurora (1-64 nodes) and Polaris (1-8 nodes), before and after the fix"/>
           <p:cNvPicPr>
             <a:picLocks noChangeAspect="1"/>
           </p:cNvPicPr>
@@ -5374,8 +5751,8 @@
         </p:blipFill>
         <p:spPr>
           <a:xfrm>
-            <a:off x="502920" y="1828800"/>
-            <a:ext cx="7863840" cy="3024554"/>
+            <a:off x="502920" y="1691640"/>
+            <a:ext cx="5284381" cy="3246120"/>
           </a:xfrm>
           <a:prstGeom prst="rect">
             <a:avLst/>
@@ -5392,8 +5769,8 @@
         </p:nvSpPr>
         <p:spPr>
           <a:xfrm>
-            <a:off x="8686800" y="1783080"/>
-            <a:ext cx="3108960" cy="1005840"/>
+            <a:off x="6263640" y="1691640"/>
+            <a:ext cx="2697480" cy="868680"/>
           </a:xfrm>
           <a:prstGeom prst="rect">
             <a:avLst/>
@@ -5408,16 +5785,16 @@
               <a:buNone/>
             </a:pPr>
             <a:r>
-              <a:rPr lang="en-US" sz="6600" dirty="0">
+              <a:rPr lang="en-US" sz="5400" dirty="0">
                 <a:solidFill>
                   <a:srgbClr val="03BA81"/>
                 </a:solidFill>
                 <a:latin typeface="Lexend"/>
                 <a:cs typeface="Lexend"/>
               </a:rPr>
-              <a:t>12×</a:t>
-            </a:r>
-            <a:endParaRPr lang="en-US" sz="6600"/>
+              <a:t>58%</a:t>
+            </a:r>
+            <a:endParaRPr lang="en-US" sz="5400"/>
           </a:p>
         </p:txBody>
       </p:sp>
@@ -5431,8 +5808,8 @@
         </p:nvSpPr>
         <p:spPr>
           <a:xfrm>
-            <a:off x="8686800" y="2788920"/>
-            <a:ext cx="3108960" cy="731520"/>
+            <a:off x="6263640" y="2560320"/>
+            <a:ext cx="2697480" cy="685800"/>
           </a:xfrm>
           <a:prstGeom prst="rect">
             <a:avLst/>
@@ -5447,16 +5824,16 @@
               <a:buNone/>
             </a:pPr>
             <a:r>
-              <a:rPr lang="en-US" sz="1400" dirty="0">
+              <a:rPr lang="en-US" sz="1300" dirty="0">
                 <a:solidFill>
                   <a:srgbClr val="000000"/>
                 </a:solidFill>
                 <a:latin typeface="Poppins"/>
                 <a:cs typeface="Poppins"/>
               </a:rPr>
-              <a:t>faster per step on Aurora at 1,536 ranks (16 nodes)</a:t>
-            </a:r>
-            <a:endParaRPr lang="en-US" sz="1400"/>
+              <a:t>efficiency vs 1 node at 64 Aurora nodes (6,144 ranks)</a:t>
+            </a:r>
+            <a:endParaRPr lang="en-US" sz="1300"/>
           </a:p>
         </p:txBody>
       </p:sp>
@@ -5470,8 +5847,8 @@
         </p:nvSpPr>
         <p:spPr>
           <a:xfrm>
-            <a:off x="8686800" y="3657600"/>
-            <a:ext cx="3108960" cy="548640"/>
+            <a:off x="9098280" y="1691640"/>
+            <a:ext cx="2697480" cy="868680"/>
           </a:xfrm>
           <a:prstGeom prst="rect">
             <a:avLst/>
@@ -5486,26 +5863,16 @@
               <a:buNone/>
             </a:pPr>
             <a:r>
-              <a:rPr lang="en-US" sz="3000" dirty="0">
+              <a:rPr lang="en-US" sz="5400" dirty="0">
                 <a:solidFill>
                   <a:srgbClr val="000000"/>
                 </a:solidFill>
                 <a:latin typeface="Lexend"/>
                 <a:cs typeface="Lexend"/>
               </a:rPr>
-              <a:t>75% </a:t>
-            </a:r>
-            <a:r>
-              <a:rPr lang="en-US" sz="3000" dirty="0">
-                <a:solidFill>
-                  <a:srgbClr val="03BA81"/>
-                </a:solidFill>
-                <a:latin typeface="Lexend"/>
-                <a:cs typeface="Lexend"/>
-              </a:rPr>
-              <a:t>/ 80%</a:t>
-            </a:r>
-            <a:endParaRPr lang="en-US" sz="3000"/>
+              <a:t>315 M</a:t>
+            </a:r>
+            <a:endParaRPr lang="en-US" sz="5400"/>
           </a:p>
         </p:txBody>
       </p:sp>
@@ -5519,8 +5886,8 @@
         </p:nvSpPr>
         <p:spPr>
           <a:xfrm>
-            <a:off x="8686800" y="4206240"/>
-            <a:ext cx="3108960" cy="685800"/>
+            <a:off x="9098280" y="2560320"/>
+            <a:ext cx="2697480" cy="685800"/>
           </a:xfrm>
           <a:prstGeom prst="rect">
             <a:avLst/>
@@ -5542,12 +5909,401 @@
                 <a:latin typeface="Poppins"/>
                 <a:cs typeface="Poppins"/>
               </a:rPr>
-              <a:t>efficiency: Aurora 1→16 nodes / Polaris 1→8 nodes (14.7× faster)</a:t>
+              <a:t>particles at 64 nodes, and no particle lost in any run</a:t>
             </a:r>
             <a:endParaRPr lang="en-US" sz="1300"/>
           </a:p>
         </p:txBody>
       </p:sp>
+      <p:sp>
+        <p:nvSpPr>
+          <p:cNvPr id="76" name="TextBox 76"/>
+          <p:cNvSpPr txBox="1">
+            <a:spLocks noGrp="1"/>
+          </p:cNvSpPr>
+          <p:nvPr/>
+        </p:nvSpPr>
+        <p:spPr>
+          <a:xfrm>
+            <a:off x="6263640" y="3383280"/>
+            <a:ext cx="2697480" cy="868680"/>
+          </a:xfrm>
+          <a:prstGeom prst="rect">
+            <a:avLst/>
+          </a:prstGeom>
+          <a:noFill/>
+        </p:spPr>
+        <p:txBody>
+          <a:bodyPr lIns="0" tIns="0" rIns="0" bIns="0" wrap="square"/>
+          <a:lstStyle/>
+          <a:p>
+            <a:pPr algn="l">
+              <a:buNone/>
+            </a:pPr>
+            <a:r>
+              <a:rPr lang="en-US" sz="5400" dirty="0">
+                <a:solidFill>
+                  <a:srgbClr val="03BA81"/>
+                </a:solidFill>
+                <a:latin typeface="Lexend"/>
+                <a:cs typeface="Lexend"/>
+              </a:rPr>
+              <a:t>12×</a:t>
+            </a:r>
+            <a:endParaRPr lang="en-US" sz="5400"/>
+          </a:p>
+        </p:txBody>
+      </p:sp>
+      <p:sp>
+        <p:nvSpPr>
+          <p:cNvPr id="77" name="TextBox 77"/>
+          <p:cNvSpPr txBox="1">
+            <a:spLocks noGrp="1"/>
+          </p:cNvSpPr>
+          <p:nvPr/>
+        </p:nvSpPr>
+        <p:spPr>
+          <a:xfrm>
+            <a:off x="6263640" y="4251960"/>
+            <a:ext cx="2697480" cy="685800"/>
+          </a:xfrm>
+          <a:prstGeom prst="rect">
+            <a:avLst/>
+          </a:prstGeom>
+          <a:noFill/>
+        </p:spPr>
+        <p:txBody>
+          <a:bodyPr lIns="0" tIns="0" rIns="0" bIns="0" wrap="square"/>
+          <a:lstStyle/>
+          <a:p>
+            <a:pPr algn="l">
+              <a:buNone/>
+            </a:pPr>
+            <a:r>
+              <a:rPr lang="en-US" sz="1300" dirty="0">
+                <a:solidFill>
+                  <a:srgbClr val="000000"/>
+                </a:solidFill>
+                <a:latin typeface="Poppins"/>
+                <a:cs typeface="Poppins"/>
+              </a:rPr>
+              <a:t>faster per step after the fix (Aurora, 16 nodes)</a:t>
+            </a:r>
+            <a:endParaRPr lang="en-US" sz="1300"/>
+          </a:p>
+        </p:txBody>
+      </p:sp>
+      <p:sp>
+        <p:nvSpPr>
+          <p:cNvPr id="78" name="TextBox 78"/>
+          <p:cNvSpPr txBox="1">
+            <a:spLocks noGrp="1"/>
+          </p:cNvSpPr>
+          <p:nvPr/>
+        </p:nvSpPr>
+        <p:spPr>
+          <a:xfrm>
+            <a:off x="9098280" y="3383280"/>
+            <a:ext cx="2697480" cy="868680"/>
+          </a:xfrm>
+          <a:prstGeom prst="rect">
+            <a:avLst/>
+          </a:prstGeom>
+          <a:noFill/>
+        </p:spPr>
+        <p:txBody>
+          <a:bodyPr lIns="0" tIns="0" rIns="0" bIns="0" wrap="square"/>
+          <a:lstStyle/>
+          <a:p>
+            <a:pPr algn="l">
+              <a:buNone/>
+            </a:pPr>
+            <a:r>
+              <a:rPr lang="en-US" sz="5400" dirty="0">
+                <a:solidFill>
+                  <a:srgbClr val="000000"/>
+                </a:solidFill>
+                <a:latin typeface="Lexend"/>
+                <a:cs typeface="Lexend"/>
+              </a:rPr>
+              <a:t>75%</a:t>
+            </a:r>
+            <a:endParaRPr lang="en-US" sz="5400"/>
+          </a:p>
+        </p:txBody>
+      </p:sp>
+      <p:sp>
+        <p:nvSpPr>
+          <p:cNvPr id="79" name="TextBox 79"/>
+          <p:cNvSpPr txBox="1">
+            <a:spLocks noGrp="1"/>
+          </p:cNvSpPr>
+          <p:nvPr/>
+        </p:nvSpPr>
+        <p:spPr>
+          <a:xfrm>
+            <a:off x="9098280" y="4251960"/>
+            <a:ext cx="2697480" cy="685800"/>
+          </a:xfrm>
+          <a:prstGeom prst="rect">
+            <a:avLst/>
+          </a:prstGeom>
+          <a:noFill/>
+        </p:spPr>
+        <p:txBody>
+          <a:bodyPr lIns="0" tIns="0" rIns="0" bIns="0" wrap="square"/>
+          <a:lstStyle/>
+          <a:p>
+            <a:pPr algn="l">
+              <a:buNone/>
+            </a:pPr>
+            <a:r>
+              <a:rPr lang="en-US" sz="1300" dirty="0">
+                <a:solidFill>
+                  <a:srgbClr val="000000"/>
+                </a:solidFill>
+                <a:latin typeface="Poppins"/>
+                <a:cs typeface="Poppins"/>
+              </a:rPr>
+              <a:t>at 16 Aurora nodes (Polaris: 80% at 8 nodes)</a:t>
+            </a:r>
+            <a:endParaRPr lang="en-US" sz="1300"/>
+          </a:p>
+        </p:txBody>
+      </p:sp>
+    </p:spTree>
+  </p:cSld>
+  <p:clrMapOvr>
+    <a:masterClrMapping/>
+  </p:clrMapOvr>
+</p:sld>
+</file>
+
+<file path=ppt/slides/slide18.xml><?xml version="1.0" encoding="utf-8"?>
+<p:sld xmlns:a="http://schemas.openxmlformats.org/drawingml/2006/main" xmlns:r="http://schemas.openxmlformats.org/officeDocument/2006/relationships" xmlns:p="http://schemas.openxmlformats.org/presentationml/2006/main">
+  <p:cSld name="Slide 14">
+    <p:spTree>
+      <p:nvGrpSpPr>
+        <p:cNvPr id="1" name=""/>
+        <p:cNvGrpSpPr/>
+        <p:nvPr/>
+      </p:nvGrpSpPr>
+      <p:grpSpPr>
+        <a:xfrm>
+          <a:off x="0" y="0"/>
+          <a:ext cx="0" cy="0"/>
+          <a:chOff x="0" y="0"/>
+          <a:chExt cx="0" cy="0"/>
+        </a:xfrm>
+      </p:grpSpPr>
+      <p:sp>
+        <p:nvSpPr>
+          <p:cNvPr id="2" name="Text 0"/>
+          <p:cNvSpPr/>
+          <p:nvPr/>
+        </p:nvSpPr>
+        <p:spPr>
+          <a:xfrm>
+            <a:off x="394106" y="228600"/>
+            <a:ext cx="5486400" cy="309067"/>
+          </a:xfrm>
+          <a:prstGeom prst="rect">
+            <a:avLst/>
+          </a:prstGeom>
+          <a:noFill/>
+          <a:ln/>
+        </p:spPr>
+        <p:txBody>
+          <a:bodyPr wrap="square" rtlCol="0" anchor="t"/>
+          <a:lstStyle/>
+          <a:p>
+            <a:pPr algn="l">
+              <a:buNone/>
+            </a:pPr>
+            <a:r>
+              <a:rPr lang="en-US" sz="1200" dirty="0">
+                <a:solidFill>
+                  <a:srgbClr val="000000"/>
+                </a:solidFill>
+                <a:latin typeface="Lexend"/>
+                <a:cs typeface="Lexend"/>
+              </a:rPr>
+              <a:t>CCS 2026 · Sharma &amp; Knepley</a:t>
+            </a:r>
+            <a:endParaRPr lang="en-US" sz="1200"/>
+          </a:p>
+        </p:txBody>
+      </p:sp>
+      <p:sp>
+        <p:nvSpPr>
+          <p:cNvPr id="3" name="Text 1"/>
+          <p:cNvSpPr/>
+          <p:nvPr/>
+        </p:nvSpPr>
+        <p:spPr>
+          <a:xfrm>
+            <a:off x="394106" y="6320333"/>
+            <a:ext cx="5486400" cy="312725"/>
+          </a:xfrm>
+          <a:prstGeom prst="rect">
+            <a:avLst/>
+          </a:prstGeom>
+          <a:noFill/>
+          <a:ln/>
+        </p:spPr>
+        <p:txBody>
+          <a:bodyPr wrap="square" rtlCol="0" anchor="t"/>
+          <a:lstStyle/>
+          <a:p>
+            <a:pPr algn="l">
+              <a:buNone/>
+            </a:pPr>
+            <a:r>
+              <a:rPr lang="en-US" sz="1200" dirty="0">
+                <a:solidFill>
+                  <a:srgbClr val="000000"/>
+                </a:solidFill>
+                <a:latin typeface="Poppins"/>
+                <a:cs typeface="Poppins"/>
+              </a:rPr>
+              <a:t>University at Buffalo (SUNY)</a:t>
+            </a:r>
+            <a:endParaRPr lang="en-US" sz="1200"/>
+          </a:p>
+        </p:txBody>
+      </p:sp>
+      <p:sp>
+        <p:nvSpPr>
+          <p:cNvPr id="4" name="Text 2"/>
+          <p:cNvSpPr/>
+          <p:nvPr/>
+        </p:nvSpPr>
+        <p:spPr>
+          <a:xfrm>
+            <a:off x="8876995" y="6320333"/>
+            <a:ext cx="2920594" cy="312725"/>
+          </a:xfrm>
+          <a:prstGeom prst="rect">
+            <a:avLst/>
+          </a:prstGeom>
+          <a:noFill/>
+          <a:ln/>
+        </p:spPr>
+        <p:txBody>
+          <a:bodyPr wrap="square" rtlCol="0" anchor="t"/>
+          <a:lstStyle/>
+          <a:p>
+            <a:pPr algn="r">
+              <a:buNone/>
+            </a:pPr>
+            <a:r>
+              <a:rPr lang="en-US" sz="1200" dirty="0">
+                <a:solidFill>
+                  <a:srgbClr val="000000"/>
+                </a:solidFill>
+                <a:latin typeface="Poppins"/>
+                <a:cs typeface="Poppins"/>
+              </a:rPr>
+              <a:t>13</a:t>
+            </a:r>
+            <a:endParaRPr lang="en-US" sz="1200"/>
+          </a:p>
+        </p:txBody>
+      </p:sp>
+      <p:sp>
+        <p:nvSpPr>
+          <p:cNvPr id="25" name="Text 23"/>
+          <p:cNvSpPr/>
+          <p:nvPr/>
+        </p:nvSpPr>
+        <p:spPr>
+          <a:xfrm>
+            <a:off x="612648" y="841248"/>
+            <a:ext cx="10972800" cy="777240"/>
+          </a:xfrm>
+          <a:prstGeom prst="rect">
+            <a:avLst/>
+          </a:prstGeom>
+          <a:noFill/>
+          <a:ln/>
+        </p:spPr>
+        <p:txBody>
+          <a:bodyPr wrap="square" rtlCol="0" anchor="t"/>
+          <a:lstStyle/>
+          <a:p>
+            <a:pPr algn="l">
+              <a:buNone/>
+            </a:pPr>
+            <a:r>
+              <a:rPr lang="en-US" sz="4000" dirty="0">
+                <a:solidFill>
+                  <a:srgbClr val="03BA81"/>
+                </a:solidFill>
+                <a:latin typeface="Lexend"/>
+                <a:cs typeface="Lexend"/>
+              </a:rPr>
+              <a:t>Backup: </a:t>
+            </a:r>
+            <a:r>
+              <a:rPr lang="en-US" sz="4000" dirty="0">
+                <a:solidFill>
+                  <a:srgbClr val="000000"/>
+                </a:solidFill>
+                <a:latin typeface="Lexend"/>
+                <a:cs typeface="Lexend"/>
+              </a:rPr>
+              <a:t>strong scaling</a:t>
+            </a:r>
+            <a:endParaRPr lang="en-US" sz="4000"/>
+          </a:p>
+        </p:txBody>
+      </p:sp>
+      <p:sp>
+        <p:nvSpPr>
+          <p:cNvPr id="26" name="Shape 24"/>
+          <p:cNvSpPr/>
+          <p:nvPr/>
+        </p:nvSpPr>
+        <p:spPr>
+          <a:xfrm>
+            <a:off x="612648" y="658368"/>
+            <a:ext cx="1273759" cy="102413"/>
+          </a:xfrm>
+          <a:prstGeom prst="roundRect">
+            <a:avLst>
+              <a:gd name="adj" fmla="val 50000"/>
+            </a:avLst>
+          </a:prstGeom>
+          <a:solidFill>
+            <a:srgbClr val="03BA81"/>
+          </a:solidFill>
+          <a:ln/>
+        </p:spPr>
+      </p:sp>
+      <p:pic>
+        <p:nvPicPr>
+          <p:cNvPr id="70" name="Picture 70" descr="Strong scaling of a fixed 9.83M-particle problem: wall time and efficiency vs nodes on Aurora and Polaris"/>
+          <p:cNvPicPr>
+            <a:picLocks noChangeAspect="1"/>
+          </p:cNvPicPr>
+          <p:nvPr/>
+        </p:nvPicPr>
+        <p:blipFill>
+          <a:blip r:embed="rIdP4a"/>
+          <a:stretch>
+            <a:fillRect/>
+          </a:stretch>
+        </p:blipFill>
+        <p:spPr>
+          <a:xfrm>
+            <a:off x="883768" y="1645920"/>
+            <a:ext cx="10424160" cy="3980134"/>
+          </a:xfrm>
+          <a:prstGeom prst="rect">
+            <a:avLst/>
+          </a:prstGeom>
+        </p:spPr>
+      </p:pic>
       <p:sp>
         <p:nvSpPr>
           <p:cNvPr id="75" name="TextBox 75"/>
@@ -5558,8 +6314,8 @@
         </p:nvSpPr>
         <p:spPr>
           <a:xfrm>
-            <a:off x="612648" y="5074920"/>
-            <a:ext cx="10972800" cy="1097280"/>
+            <a:off x="612648" y="5669280"/>
+            <a:ext cx="10972800" cy="594360"/>
           </a:xfrm>
           <a:prstGeom prst="rect">
             <a:avLst/>
@@ -5571,58 +6327,524 @@
           <a:lstStyle/>
           <a:p>
             <a:pPr algn="l">
-              <a:spcAft>
-                <a:spcPts val="600"/>
-              </a:spcAft>
-              <a:buNone/>
-            </a:pPr>
-            <a:r>
-              <a:rPr lang="en-US" sz="1500" dirty="0" b="1">
+              <a:buNone/>
+            </a:pPr>
+            <a:r>
+              <a:rPr lang="en-US" sz="1400" dirty="0" b="1">
                 <a:solidFill>
                   <a:srgbClr val="03BA81"/>
                 </a:solidFill>
                 <a:latin typeface="Poppins"/>
                 <a:cs typeface="Poppins"/>
               </a:rPr>
-              <a:t>Cause: </a:t>
-            </a:r>
-            <a:r>
-              <a:rPr lang="en-US" sz="1500" dirty="0">
+              <a:t>Fixed problem, more nodes: </a:t>
+            </a:r>
+            <a:r>
+              <a:rPr lang="en-US" sz="1400" dirty="0">
                 <a:solidFill>
                   <a:srgbClr val="000000"/>
                 </a:solidFill>
                 <a:latin typeface="Poppins"/>
                 <a:cs typeface="Poppins"/>
               </a:rPr>
-              <a:t>the periodic-wrap rank’s point-location hash spanned the whole domain, so one rank did up to 41× the work. A local ex2 patch fixed it (before: 3% efficiency).</a:t>
-            </a:r>
-            <a:endParaRPr lang="en-US" sz="1500"/>
-          </a:p>
+              <a:t>9.83 M particles, 100 steps. Aurora 4.63× at 16 nodes (efficiency 0.29): only 32 cells per rank are left. Polaris 5.38× at 8 nodes (0.67).</a:t>
+            </a:r>
+            <a:endParaRPr lang="en-US" sz="1400"/>
+          </a:p>
+        </p:txBody>
+      </p:sp>
+    </p:spTree>
+  </p:cSld>
+  <p:clrMapOvr>
+    <a:masterClrMapping/>
+  </p:clrMapOvr>
+</p:sld>
+</file>
+
+<file path=ppt/slides/slide19.xml><?xml version="1.0" encoding="utf-8"?>
+<p:sld xmlns:a="http://schemas.openxmlformats.org/drawingml/2006/main" xmlns:r="http://schemas.openxmlformats.org/officeDocument/2006/relationships" xmlns:p="http://schemas.openxmlformats.org/presentationml/2006/main">
+  <p:cSld name="Slide 14">
+    <p:spTree>
+      <p:nvGrpSpPr>
+        <p:cNvPr id="1" name=""/>
+        <p:cNvGrpSpPr/>
+        <p:nvPr/>
+      </p:nvGrpSpPr>
+      <p:grpSpPr>
+        <a:xfrm>
+          <a:off x="0" y="0"/>
+          <a:ext cx="0" cy="0"/>
+          <a:chOff x="0" y="0"/>
+          <a:chExt cx="0" cy="0"/>
+        </a:xfrm>
+      </p:grpSpPr>
+      <p:sp>
+        <p:nvSpPr>
+          <p:cNvPr id="2" name="Text 0"/>
+          <p:cNvSpPr/>
+          <p:nvPr/>
+        </p:nvSpPr>
+        <p:spPr>
+          <a:xfrm>
+            <a:off x="394106" y="228600"/>
+            <a:ext cx="5486400" cy="309067"/>
+          </a:xfrm>
+          <a:prstGeom prst="rect">
+            <a:avLst/>
+          </a:prstGeom>
+          <a:noFill/>
+          <a:ln/>
+        </p:spPr>
+        <p:txBody>
+          <a:bodyPr wrap="square" rtlCol="0" anchor="t"/>
+          <a:lstStyle/>
           <a:p>
             <a:pPr algn="l">
               <a:buNone/>
             </a:pPr>
             <a:r>
-              <a:rPr lang="en-US" sz="1500" dirty="0" b="1">
-                <a:solidFill>
-                  <a:srgbClr val="03BA81"/>
+              <a:rPr lang="en-US" sz="1200" dirty="0">
+                <a:solidFill>
+                  <a:srgbClr val="000000"/>
+                </a:solidFill>
+                <a:latin typeface="Lexend"/>
+                <a:cs typeface="Lexend"/>
+              </a:rPr>
+              <a:t>CCS 2026 · Sharma &amp; Knepley</a:t>
+            </a:r>
+            <a:endParaRPr lang="en-US" sz="1200"/>
+          </a:p>
+        </p:txBody>
+      </p:sp>
+      <p:sp>
+        <p:nvSpPr>
+          <p:cNvPr id="3" name="Text 1"/>
+          <p:cNvSpPr/>
+          <p:nvPr/>
+        </p:nvSpPr>
+        <p:spPr>
+          <a:xfrm>
+            <a:off x="394106" y="6320333"/>
+            <a:ext cx="5486400" cy="312725"/>
+          </a:xfrm>
+          <a:prstGeom prst="rect">
+            <a:avLst/>
+          </a:prstGeom>
+          <a:noFill/>
+          <a:ln/>
+        </p:spPr>
+        <p:txBody>
+          <a:bodyPr wrap="square" rtlCol="0" anchor="t"/>
+          <a:lstStyle/>
+          <a:p>
+            <a:pPr algn="l">
+              <a:buNone/>
+            </a:pPr>
+            <a:r>
+              <a:rPr lang="en-US" sz="1200" dirty="0">
+                <a:solidFill>
+                  <a:srgbClr val="000000"/>
                 </a:solidFill>
                 <a:latin typeface="Poppins"/>
                 <a:cs typeface="Poppins"/>
               </a:rPr>
-              <a:t>Invariants: </a:t>
-            </a:r>
-            <a:r>
-              <a:rPr lang="en-US" sz="1500" dirty="0">
+              <a:t>University at Buffalo (SUNY)</a:t>
+            </a:r>
+            <a:endParaRPr lang="en-US" sz="1200"/>
+          </a:p>
+        </p:txBody>
+      </p:sp>
+      <p:sp>
+        <p:nvSpPr>
+          <p:cNvPr id="4" name="Text 2"/>
+          <p:cNvSpPr/>
+          <p:nvPr/>
+        </p:nvSpPr>
+        <p:spPr>
+          <a:xfrm>
+            <a:off x="8876995" y="6320333"/>
+            <a:ext cx="2920594" cy="312725"/>
+          </a:xfrm>
+          <a:prstGeom prst="rect">
+            <a:avLst/>
+          </a:prstGeom>
+          <a:noFill/>
+          <a:ln/>
+        </p:spPr>
+        <p:txBody>
+          <a:bodyPr wrap="square" rtlCol="0" anchor="t"/>
+          <a:lstStyle/>
+          <a:p>
+            <a:pPr algn="r">
+              <a:buNone/>
+            </a:pPr>
+            <a:r>
+              <a:rPr lang="en-US" sz="1200" dirty="0">
                 <a:solidFill>
                   <a:srgbClr val="000000"/>
                 </a:solidFill>
                 <a:latin typeface="Poppins"/>
                 <a:cs typeface="Poppins"/>
               </a:rPr>
-              <a:t>particle count and charge exactly conserved in every run, up to 78.6 M particles.</a:t>
-            </a:r>
-            <a:endParaRPr lang="en-US" sz="1500"/>
+              <a:t>14</a:t>
+            </a:r>
+            <a:endParaRPr lang="en-US" sz="1200"/>
+          </a:p>
+        </p:txBody>
+      </p:sp>
+      <p:sp>
+        <p:nvSpPr>
+          <p:cNvPr id="25" name="Text 23"/>
+          <p:cNvSpPr/>
+          <p:nvPr/>
+        </p:nvSpPr>
+        <p:spPr>
+          <a:xfrm>
+            <a:off x="612648" y="841248"/>
+            <a:ext cx="10972800" cy="777240"/>
+          </a:xfrm>
+          <a:prstGeom prst="rect">
+            <a:avLst/>
+          </a:prstGeom>
+          <a:noFill/>
+          <a:ln/>
+        </p:spPr>
+        <p:txBody>
+          <a:bodyPr wrap="square" rtlCol="0" anchor="t"/>
+          <a:lstStyle/>
+          <a:p>
+            <a:pPr algn="l">
+              <a:buNone/>
+            </a:pPr>
+            <a:r>
+              <a:rPr lang="en-US" sz="4000" dirty="0">
+                <a:solidFill>
+                  <a:srgbClr val="03BA81"/>
+                </a:solidFill>
+                <a:latin typeface="Lexend"/>
+                <a:cs typeface="Lexend"/>
+              </a:rPr>
+              <a:t>Backup: </a:t>
+            </a:r>
+            <a:r>
+              <a:rPr lang="en-US" sz="4000" dirty="0">
+                <a:solidFill>
+                  <a:srgbClr val="000000"/>
+                </a:solidFill>
+                <a:latin typeface="Lexend"/>
+                <a:cs typeface="Lexend"/>
+              </a:rPr>
+              <a:t>long-run conservation</a:t>
+            </a:r>
+            <a:endParaRPr lang="en-US" sz="4000"/>
+          </a:p>
+        </p:txBody>
+      </p:sp>
+      <p:sp>
+        <p:nvSpPr>
+          <p:cNvPr id="26" name="Shape 24"/>
+          <p:cNvSpPr/>
+          <p:nvPr/>
+        </p:nvSpPr>
+        <p:spPr>
+          <a:xfrm>
+            <a:off x="612648" y="658368"/>
+            <a:ext cx="1273759" cy="102413"/>
+          </a:xfrm>
+          <a:prstGeom prst="roundRect">
+            <a:avLst>
+              <a:gd name="adj" fmla="val 50000"/>
+            </a:avLst>
+          </a:prstGeom>
+          <a:solidFill>
+            <a:srgbClr val="03BA81"/>
+          </a:solidFill>
+          <a:ln/>
+        </p:spPr>
+      </p:sp>
+      <p:pic>
+        <p:nvPicPr>
+          <p:cNvPr id="70" name="Picture 70" descr="Particle pushers over 10^8 steps: energy and momentum error for Boris, RK4 and TSDISCGRAD"/>
+          <p:cNvPicPr>
+            <a:picLocks noChangeAspect="1"/>
+          </p:cNvPicPr>
+          <p:nvPr/>
+        </p:nvPicPr>
+        <p:blipFill>
+          <a:blip r:embed="rIdP4b"/>
+          <a:stretch>
+            <a:fillRect/>
+          </a:stretch>
+        </p:blipFill>
+        <p:spPr>
+          <a:xfrm>
+            <a:off x="457200" y="1645920"/>
+            <a:ext cx="5172891" cy="3291840"/>
+          </a:xfrm>
+          <a:prstGeom prst="rect">
+            <a:avLst/>
+          </a:prstGeom>
+        </p:spPr>
+      </p:pic>
+      <p:pic>
+        <p:nvPicPr>
+          <p:cNvPr id="71" name="Picture 71" descr="Long-run Landau damping on Aurora and Polaris: field amplitude and total-energy error"/>
+          <p:cNvPicPr>
+            <a:picLocks noChangeAspect="1"/>
+          </p:cNvPicPr>
+          <p:nvPr/>
+        </p:nvPicPr>
+        <p:blipFill>
+          <a:blip r:embed="rIdP4c"/>
+          <a:stretch>
+            <a:fillRect/>
+          </a:stretch>
+        </p:blipFill>
+        <p:spPr>
+          <a:xfrm>
+            <a:off x="5812971" y="1812145"/>
+            <a:ext cx="5918781" cy="2959390"/>
+          </a:xfrm>
+          <a:prstGeom prst="rect">
+            <a:avLst/>
+          </a:prstGeom>
+        </p:spPr>
+      </p:pic>
+      <p:sp>
+        <p:nvSpPr>
+          <p:cNvPr id="72" name="TextBox 72"/>
+          <p:cNvSpPr txBox="1">
+            <a:spLocks noGrp="1"/>
+          </p:cNvSpPr>
+          <p:nvPr/>
+        </p:nvSpPr>
+        <p:spPr>
+          <a:xfrm>
+            <a:off x="457200" y="5074920"/>
+            <a:ext cx="5172891" cy="1188720"/>
+          </a:xfrm>
+          <a:prstGeom prst="rect">
+            <a:avLst/>
+          </a:prstGeom>
+          <a:noFill/>
+        </p:spPr>
+        <p:txBody>
+          <a:bodyPr lIns="0" tIns="0" rIns="0" bIns="0" wrap="square"/>
+          <a:lstStyle/>
+          <a:p>
+            <a:pPr algn="l">
+              <a:buNone/>
+            </a:pPr>
+            <a:r>
+              <a:rPr lang="en-US" sz="1300" dirty="0" b="1">
+                <a:solidFill>
+                  <a:srgbClr val="03BA81"/>
+                </a:solidFill>
+                <a:latin typeface="Poppins"/>
+                <a:cs typeface="Poppins"/>
+              </a:rPr>
+              <a:t>Pushers, 10</a:t>
+            </a:r>
+            <a:r>
+              <a:rPr lang="en-US" sz="1300" dirty="0" b="1" baseline="30000">
+                <a:solidFill>
+                  <a:srgbClr val="03BA81"/>
+                </a:solidFill>
+                <a:latin typeface="Poppins"/>
+                <a:cs typeface="Poppins"/>
+              </a:rPr>
+              <a:t>8</a:t>
+            </a:r>
+            <a:r>
+              <a:rPr lang="en-US" sz="1300" dirty="0" b="1">
+                <a:solidFill>
+                  <a:srgbClr val="03BA81"/>
+                </a:solidFill>
+                <a:latin typeface="Poppins"/>
+                <a:cs typeface="Poppins"/>
+              </a:rPr>
+              <a:t> steps: </a:t>
+            </a:r>
+            <a:r>
+              <a:rPr lang="en-US" sz="1300" dirty="0">
+                <a:solidFill>
+                  <a:srgbClr val="000000"/>
+                </a:solidFill>
+                <a:latin typeface="Poppins"/>
+                <a:cs typeface="Poppins"/>
+              </a:rPr>
+              <a:t>Boris bounded (Solov'ev energy error 1.2×10</a:t>
+            </a:r>
+            <a:r>
+              <a:rPr lang="en-US" sz="1300" dirty="0" baseline="30000">
+                <a:solidFill>
+                  <a:srgbClr val="000000"/>
+                </a:solidFill>
+                <a:latin typeface="Poppins"/>
+                <a:cs typeface="Poppins"/>
+              </a:rPr>
+              <a:t>−12</a:t>
+            </a:r>
+            <a:r>
+              <a:rPr lang="en-US" sz="1300" dirty="0">
+                <a:solidFill>
+                  <a:srgbClr val="000000"/>
+                </a:solidFill>
+                <a:latin typeface="Poppins"/>
+                <a:cs typeface="Poppins"/>
+              </a:rPr>
+              <a:t>). RK4 drifts 28% (Solov'ev) / 67% (uniform B). TSDISCGRAD stalled (solver failures shrank the step), so no 10</a:t>
+            </a:r>
+            <a:r>
+              <a:rPr lang="en-US" sz="1300" dirty="0" baseline="30000">
+                <a:solidFill>
+                  <a:srgbClr val="000000"/>
+                </a:solidFill>
+                <a:latin typeface="Poppins"/>
+                <a:cs typeface="Poppins"/>
+              </a:rPr>
+              <a:t>8</a:t>
+            </a:r>
+            <a:r>
+              <a:rPr lang="en-US" sz="1300" dirty="0">
+                <a:solidFill>
+                  <a:srgbClr val="000000"/>
+                </a:solidFill>
+                <a:latin typeface="Poppins"/>
+                <a:cs typeface="Poppins"/>
+              </a:rPr>
+              <a:t> result.</a:t>
+            </a:r>
+            <a:endParaRPr lang="en-US" sz="1300"/>
+          </a:p>
+        </p:txBody>
+      </p:sp>
+      <p:sp>
+        <p:nvSpPr>
+          <p:cNvPr id="73" name="TextBox 73"/>
+          <p:cNvSpPr txBox="1">
+            <a:spLocks noGrp="1"/>
+          </p:cNvSpPr>
+          <p:nvPr/>
+        </p:nvSpPr>
+        <p:spPr>
+          <a:xfrm>
+            <a:off x="5812971" y="5074920"/>
+            <a:ext cx="5918781" cy="1188720"/>
+          </a:xfrm>
+          <a:prstGeom prst="rect">
+            <a:avLst/>
+          </a:prstGeom>
+          <a:noFill/>
+        </p:spPr>
+        <p:txBody>
+          <a:bodyPr lIns="0" tIns="0" rIns="0" bIns="0" wrap="square"/>
+          <a:lstStyle/>
+          <a:p>
+            <a:pPr algn="l">
+              <a:buNone/>
+            </a:pPr>
+            <a:r>
+              <a:rPr lang="en-US" sz="1300" dirty="0" b="1">
+                <a:solidFill>
+                  <a:srgbClr val="03BA81"/>
+                </a:solidFill>
+                <a:latin typeface="Poppins"/>
+                <a:cs typeface="Poppins"/>
+              </a:rPr>
+              <a:t>Landau PIC, energy not bounded: </a:t>
+            </a:r>
+            <a:r>
+              <a:rPr lang="en-US" sz="1300" dirty="0">
+                <a:solidFill>
+                  <a:srgbClr val="000000"/>
+                </a:solidFill>
+                <a:latin typeface="Poppins"/>
+                <a:cs typeface="Poppins"/>
+              </a:rPr>
+              <a:t>dt = 0.01 stays at 3.8×10</a:t>
+            </a:r>
+            <a:r>
+              <a:rPr lang="en-US" sz="1300" dirty="0" baseline="30000">
+                <a:solidFill>
+                  <a:srgbClr val="000000"/>
+                </a:solidFill>
+                <a:latin typeface="Poppins"/>
+                <a:cs typeface="Poppins"/>
+              </a:rPr>
+              <a:t>−6</a:t>
+            </a:r>
+            <a:r>
+              <a:rPr lang="en-US" sz="1300" dirty="0">
+                <a:solidFill>
+                  <a:srgbClr val="000000"/>
+                </a:solidFill>
+                <a:latin typeface="Poppins"/>
+                <a:cs typeface="Poppins"/>
+              </a:rPr>
+              <a:t> (Aurora = Polaris to 10</a:t>
+            </a:r>
+            <a:r>
+              <a:rPr lang="en-US" sz="1300" dirty="0" baseline="30000">
+                <a:solidFill>
+                  <a:srgbClr val="000000"/>
+                </a:solidFill>
+                <a:latin typeface="Poppins"/>
+                <a:cs typeface="Poppins"/>
+              </a:rPr>
+              <a:t>−14</a:t>
+            </a:r>
+            <a:r>
+              <a:rPr lang="en-US" sz="1300" dirty="0">
+                <a:solidFill>
+                  <a:srgbClr val="000000"/>
+                </a:solidFill>
+                <a:latin typeface="Poppins"/>
+                <a:cs typeface="Poppins"/>
+              </a:rPr>
+              <a:t>). dt = 0.05 is flat ~10</a:t>
+            </a:r>
+            <a:r>
+              <a:rPr lang="en-US" sz="1300" dirty="0" baseline="30000">
+                <a:solidFill>
+                  <a:srgbClr val="000000"/>
+                </a:solidFill>
+                <a:latin typeface="Poppins"/>
+                <a:cs typeface="Poppins"/>
+              </a:rPr>
+              <a:t>−4</a:t>
+            </a:r>
+            <a:r>
+              <a:rPr lang="en-US" sz="1300" dirty="0">
+                <a:solidFill>
+                  <a:srgbClr val="000000"/>
+                </a:solidFill>
+                <a:latin typeface="Poppins"/>
+                <a:cs typeface="Poppins"/>
+              </a:rPr>
+              <a:t> to t ≈ 70, then grows to 4.4×10</a:t>
+            </a:r>
+            <a:r>
+              <a:rPr lang="en-US" sz="1300" dirty="0" baseline="30000">
+                <a:solidFill>
+                  <a:srgbClr val="000000"/>
+                </a:solidFill>
+                <a:latin typeface="Poppins"/>
+                <a:cs typeface="Poppins"/>
+              </a:rPr>
+              <a:t>−3</a:t>
+            </a:r>
+            <a:r>
+              <a:rPr lang="en-US" sz="1300" dirty="0">
+                <a:solidFill>
+                  <a:srgbClr val="000000"/>
+                </a:solidFill>
+                <a:latin typeface="Poppins"/>
+                <a:cs typeface="Poppins"/>
+              </a:rPr>
+              <a:t> at t = 300. 3,200 particles: ~80% heating by t = 3000.</a:t>
+            </a:r>
+            <a:endParaRPr lang="en-US" sz="1300"/>
           </a:p>
         </p:txBody>
       </p:sp>
@@ -8065,7 +9287,7 @@
         <p:spPr>
           <a:xfrm>
             <a:off x="502920" y="1143000"/>
-            <a:ext cx="3886200" cy="457200"/>
+            <a:ext cx="3977640" cy="457200"/>
           </a:xfrm>
           <a:prstGeom prst="rect">
             <a:avLst/>
@@ -8113,7 +9335,7 @@
         <p:spPr>
           <a:xfrm>
             <a:off x="502920" y="1645920"/>
-            <a:ext cx="3749040" cy="822960"/>
+            <a:ext cx="3749040" cy="868680"/>
           </a:xfrm>
           <a:prstGeom prst="rect">
             <a:avLst/>
@@ -8136,7 +9358,7 @@
                 <a:latin typeface="Poppins"/>
                 <a:cs typeface="Poppins"/>
               </a:rPr>
-              <a:t>Fitted damping rate; linear theory predicts −0.1533</a:t>
+              <a:t>Fitted damping rate (−0.147 in a 6,000-step run); linear theory predicts −0.1533</a:t>
             </a:r>
             <a:endParaRPr lang="en-US" sz="1500"/>
           </a:p>
@@ -8150,8 +9372,8 @@
         </p:nvSpPr>
         <p:spPr>
           <a:xfrm>
-            <a:off x="502920" y="2651760"/>
-            <a:ext cx="3886200" cy="457200"/>
+            <a:off x="502920" y="2560320"/>
+            <a:ext cx="3977640" cy="457200"/>
           </a:xfrm>
           <a:prstGeom prst="rect">
             <a:avLst/>
@@ -8198,8 +9420,8 @@
         </p:nvSpPr>
         <p:spPr>
           <a:xfrm>
-            <a:off x="502920" y="3154680"/>
-            <a:ext cx="3749040" cy="822960"/>
+            <a:off x="502920" y="3063240"/>
+            <a:ext cx="3749040" cy="868680"/>
           </a:xfrm>
           <a:prstGeom prst="rect">
             <a:avLst/>
@@ -8222,7 +9444,27 @@
                 <a:latin typeface="Poppins"/>
                 <a:cs typeface="Poppins"/>
               </a:rPr>
-              <a:t>Aurora and Polaris match to every digit, at any rank count</a:t>
+              <a:t>Aurora and Polaris agree at any rank count; to 10</a:t>
+            </a:r>
+            <a:r>
+              <a:rPr lang="en-US" sz="1500" dirty="0" baseline="30000">
+                <a:solidFill>
+                  <a:srgbClr val="000000"/>
+                </a:solidFill>
+                <a:latin typeface="Poppins"/>
+                <a:cs typeface="Poppins"/>
+              </a:rPr>
+              <a:t>−14</a:t>
+            </a:r>
+            <a:r>
+              <a:rPr lang="en-US" sz="1500" dirty="0">
+                <a:solidFill>
+                  <a:srgbClr val="000000"/>
+                </a:solidFill>
+                <a:latin typeface="Poppins"/>
+                <a:cs typeface="Poppins"/>
+              </a:rPr>
+              <a:t> over 6,000 steps</a:t>
             </a:r>
             <a:endParaRPr lang="en-US" sz="1500"/>
           </a:p>
@@ -8236,8 +9478,8 @@
         </p:nvSpPr>
         <p:spPr>
           <a:xfrm>
-            <a:off x="502920" y="4160520"/>
-            <a:ext cx="3886200" cy="457200"/>
+            <a:off x="502920" y="3977640"/>
+            <a:ext cx="3977640" cy="457200"/>
           </a:xfrm>
           <a:prstGeom prst="rect">
             <a:avLst/>
@@ -8270,7 +9512,7 @@
                 <a:latin typeface="Lexend"/>
                 <a:cs typeface="Lexend"/>
               </a:rPr>
-              <a:t>Energy drift ~10⁻⁵</a:t>
+              <a:t>Energy not bounded</a:t>
             </a:r>
             <a:endParaRPr lang="en-US" sz="2200"/>
           </a:p>
@@ -8284,8 +9526,8 @@
         </p:nvSpPr>
         <p:spPr>
           <a:xfrm>
-            <a:off x="502920" y="4663440"/>
-            <a:ext cx="3749040" cy="822960"/>
+            <a:off x="502920" y="4480560"/>
+            <a:ext cx="3749040" cy="868680"/>
           </a:xfrm>
           <a:prstGeom prst="rect">
             <a:avLst/>
@@ -8308,7 +9550,27 @@
                 <a:latin typeface="Poppins"/>
                 <a:cs typeface="Poppins"/>
               </a:rPr>
-              <a:t>of total energy over 600 steps</a:t>
+              <a:t>Error ~10</a:t>
+            </a:r>
+            <a:r>
+              <a:rPr lang="en-US" sz="1500" dirty="0" baseline="30000">
+                <a:solidFill>
+                  <a:srgbClr val="000000"/>
+                </a:solidFill>
+                <a:latin typeface="Poppins"/>
+                <a:cs typeface="Poppins"/>
+              </a:rPr>
+              <a:t>−5</a:t>
+            </a:r>
+            <a:r>
+              <a:rPr lang="en-US" sz="1500" dirty="0">
+                <a:solidFill>
+                  <a:srgbClr val="000000"/>
+                </a:solidFill>
+                <a:latin typeface="Poppins"/>
+                <a:cs typeface="Poppins"/>
+              </a:rPr>
+              <a:t> over 600 steps, but long runs heat slowly: 0.4% by t = 300</a:t>
             </a:r>
             <a:endParaRPr lang="en-US" sz="1500"/>
           </a:p>

</xml_diff>